<commit_message>
Add LessonBuddy screenshot as full-page Slide 3 in presentation
4-slide deck: core question, assignments/progression, LessonBuddy, revised outcomes

https://claude.ai/code/session_011UEJexLDqRtsRVubBLCHGV
</commit_message>
<xml_diff>
--- a/AI compentency framework for TCE.pptx
+++ b/AI compentency framework for TCE.pptx
@@ -7,6 +7,7 @@
   <p:sldIdLst>
     <p:sldId id="256" r:id="rId7"/>
     <p:sldId id="257" r:id="rId8"/>
+    <p:sldId id="259" r:id="rId10"/>
     <p:sldId id="258" r:id="rId9"/>
   </p:sldIdLst>
   <p:sldSz cx="9144000" cy="6858000" type="screen4x3"/>
@@ -3958,6 +3959,79 @@
           </a:graphicData>
         </a:graphic>
       </p:graphicFrame>
+    </p:spTree>
+  </p:cSld>
+  <p:clrMapOvr>
+    <a:masterClrMapping/>
+  </p:clrMapOvr>
+</p:sld>
+</file>
+
+<file path=ppt/slides/slide4.xml><?xml version="1.0" encoding="utf-8"?>
+<p:sld xmlns:a="http://schemas.openxmlformats.org/drawingml/2006/main" xmlns:p="http://schemas.openxmlformats.org/presentationml/2006/main" xmlns:r="http://schemas.openxmlformats.org/officeDocument/2006/relationships">
+  <p:cSld>
+    <p:spTree>
+      <p:nvGrpSpPr>
+        <p:cNvPr id="1" name=""/>
+        <p:cNvGrpSpPr/>
+        <p:nvPr/>
+      </p:nvGrpSpPr>
+      <p:grpSpPr/>
+      <p:sp>
+        <p:nvSpPr>
+          <p:cNvPr id="2" name="TextBox 1"/>
+          <p:cNvSpPr txBox="1"/>
+          <p:nvPr/>
+        </p:nvSpPr>
+        <p:spPr>
+          <a:xfrm>
+            <a:off x="274320" y="137160"/>
+            <a:ext cx="8595360" cy="457200"/>
+          </a:xfrm>
+          <a:prstGeom prst="rect">
+            <a:avLst/>
+          </a:prstGeom>
+          <a:noFill/>
+        </p:spPr>
+        <p:txBody>
+          <a:bodyPr wrap="none">
+            <a:spAutoFit/>
+          </a:bodyPr>
+          <a:lstStyle/>
+          <a:p>
+            <a:pPr algn="ctr">
+              <a:defRPr sz="3200" b="1"/>
+            </a:pPr>
+            <a:r>
+              <a:t>AI in Action: LessonBuddy for Lesson Planning</a:t>
+            </a:r>
+          </a:p>
+        </p:txBody>
+      </p:sp>
+      <p:pic>
+        <p:nvPicPr>
+          <p:cNvPr id="3" name="Picture 2" descr="LessonBuddy-screenshot.png"/>
+          <p:cNvPicPr>
+            <a:picLocks noChangeAspect="1"/>
+          </p:cNvPicPr>
+          <p:nvPr/>
+        </p:nvPicPr>
+        <p:blipFill>
+          <a:blip r:embed="rId2"/>
+          <a:stretch>
+            <a:fillRect/>
+          </a:stretch>
+        </p:blipFill>
+        <p:spPr>
+          <a:xfrm>
+            <a:off x="274320" y="731520"/>
+            <a:ext cx="8595360" cy="5303520"/>
+          </a:xfrm>
+          <a:prstGeom prst="rect">
+            <a:avLst/>
+          </a:prstGeom>
+        </p:spPr>
+      </p:pic>
     </p:spTree>
   </p:cSld>
   <p:clrMapOvr>

</xml_diff>